<commit_message>
report+deck v8: regenerate from v8 master (add inkling + laguna-s-2.1); recompile PDF; portable pptxgenjs/deck paths
</commit_message>
<xml_diff>
--- a/deck/pi30_Fleet_Benchmark.pptx
+++ b/deck/pi30_Fleet_Benchmark.pptx
@@ -2254,7 +2254,7 @@
                 <a:ea typeface="Georgia" pitchFamily="34" charset="-122"/>
                 <a:cs typeface="Georgia" pitchFamily="34" charset="-120"/>
               </a:rPr>
-              <a:t>24</a:t>
+              <a:t>26</a:t>
             </a:r>
             <a:endParaRPr lang="en-US" sz="4600" dirty="0"/>
           </a:p>
@@ -2464,7 +2464,7 @@
                 <a:ea typeface="Georgia" pitchFamily="34" charset="-122"/>
                 <a:cs typeface="Georgia" pitchFamily="34" charset="-120"/>
               </a:rPr>
-              <a:t>7</a:t>
+              <a:t>8</a:t>
             </a:r>
             <a:endParaRPr lang="en-US" sz="4600" dirty="0"/>
           </a:p>
@@ -2652,7 +2652,7 @@
                 <a:ea typeface="Georgia" pitchFamily="34" charset="-122"/>
                 <a:cs typeface="Georgia" pitchFamily="34" charset="-120"/>
               </a:rPr>
-              <a:t>All 24 lanes — ranks 1–12</a:t>
+              <a:t>All 26 lanes — ranks 1–13</a:t>
             </a:r>
             <a:endParaRPr lang="en-US" sz="4000" dirty="0"/>
           </a:p>
@@ -3190,7 +3190,7 @@
                 <a:ea typeface="Calibri" pitchFamily="34" charset="-122"/>
                 <a:cs typeface="Calibri" pitchFamily="34" charset="-120"/>
               </a:rPr>
-              <a:t>kimi (Kimi-K2.6)</a:t>
+              <a:t>inkling (thinkingmachines)</a:t>
             </a:r>
             <a:endParaRPr lang="en-US" sz="1600" dirty="0"/>
           </a:p>
@@ -3229,7 +3229,7 @@
                 <a:ea typeface="Calibri" pitchFamily="34" charset="-122"/>
                 <a:cs typeface="Calibri" pitchFamily="34" charset="-120"/>
               </a:rPr>
-              <a:t>local dgx</a:t>
+              <a:t>OpenRouter</a:t>
             </a:r>
             <a:endParaRPr lang="en-US" sz="1600" dirty="0"/>
           </a:p>
@@ -3268,7 +3268,7 @@
                 <a:ea typeface="Calibri" pitchFamily="34" charset="-122"/>
                 <a:cs typeface="Calibri" pitchFamily="34" charset="-120"/>
               </a:rPr>
-              <a:t>30/30</a:t>
+              <a:t>30/30*</a:t>
             </a:r>
             <a:endParaRPr lang="en-US" sz="1600" dirty="0"/>
           </a:p>
@@ -3307,7 +3307,7 @@
                 <a:ea typeface="Calibri" pitchFamily="34" charset="-122"/>
                 <a:cs typeface="Calibri" pitchFamily="34" charset="-120"/>
               </a:rPr>
-              <a:t>3h18m</a:t>
+              <a:t>24m</a:t>
             </a:r>
             <a:endParaRPr lang="en-US" sz="1600" dirty="0"/>
           </a:p>
@@ -3410,7 +3410,7 @@
                 <a:ea typeface="Calibri" pitchFamily="34" charset="-122"/>
                 <a:cs typeface="Calibri" pitchFamily="34" charset="-120"/>
               </a:rPr>
-              <a:t>qwen36-27b</a:t>
+              <a:t>kimi (Kimi-K2.6)</a:t>
             </a:r>
             <a:endParaRPr lang="en-US" sz="1600" dirty="0"/>
           </a:p>
@@ -3449,7 +3449,7 @@
                 <a:ea typeface="Calibri" pitchFamily="34" charset="-122"/>
                 <a:cs typeface="Calibri" pitchFamily="34" charset="-120"/>
               </a:rPr>
-              <a:t>Intel PVC (1 tile)</a:t>
+              <a:t>local dgx</a:t>
             </a:r>
             <a:endParaRPr lang="en-US" sz="1600" dirty="0"/>
           </a:p>
@@ -3527,7 +3527,7 @@
                 <a:ea typeface="Calibri" pitchFamily="34" charset="-122"/>
                 <a:cs typeface="Calibri" pitchFamily="34" charset="-120"/>
               </a:rPr>
-              <a:t>1h22m</a:t>
+              <a:t>3h18m</a:t>
             </a:r>
             <a:endParaRPr lang="en-US" sz="1600" dirty="0"/>
           </a:p>
@@ -3630,7 +3630,7 @@
                 <a:ea typeface="Calibri" pitchFamily="34" charset="-122"/>
                 <a:cs typeface="Calibri" pitchFamily="34" charset="-120"/>
               </a:rPr>
-              <a:t>ornith-9b (reasoning)</a:t>
+              <a:t>qwen36-27b</a:t>
             </a:r>
             <a:endParaRPr lang="en-US" sz="1600" dirty="0"/>
           </a:p>
@@ -3747,7 +3747,7 @@
                 <a:ea typeface="Calibri" pitchFamily="34" charset="-122"/>
                 <a:cs typeface="Calibri" pitchFamily="34" charset="-120"/>
               </a:rPr>
-              <a:t>3h05m</a:t>
+              <a:t>1h22m</a:t>
             </a:r>
             <a:endParaRPr lang="en-US" sz="1600" dirty="0"/>
           </a:p>
@@ -3850,7 +3850,7 @@
                 <a:ea typeface="Calibri" pitchFamily="34" charset="-122"/>
                 <a:cs typeface="Calibri" pitchFamily="34" charset="-120"/>
               </a:rPr>
-              <a:t>uic-qwen36-35b-a3b</a:t>
+              <a:t>ornith-9b (reasoning)</a:t>
             </a:r>
             <a:endParaRPr lang="en-US" sz="1600" dirty="0"/>
           </a:p>
@@ -3889,7 +3889,7 @@
                 <a:ea typeface="Calibri" pitchFamily="34" charset="-122"/>
                 <a:cs typeface="Calibri" pitchFamily="34" charset="-120"/>
               </a:rPr>
-              <a:t>nVIDIA A100 (MoE)</a:t>
+              <a:t>Intel PVC (1 tile)</a:t>
             </a:r>
             <a:endParaRPr lang="en-US" sz="1600" dirty="0"/>
           </a:p>
@@ -3967,7 +3967,7 @@
                 <a:ea typeface="Calibri" pitchFamily="34" charset="-122"/>
                 <a:cs typeface="Calibri" pitchFamily="34" charset="-120"/>
               </a:rPr>
-              <a:t>52m</a:t>
+              <a:t>3h05m</a:t>
             </a:r>
             <a:endParaRPr lang="en-US" sz="1600" dirty="0"/>
           </a:p>
@@ -4070,7 +4070,7 @@
                 <a:ea typeface="Calibri" pitchFamily="34" charset="-122"/>
                 <a:cs typeface="Calibri" pitchFamily="34" charset="-120"/>
               </a:rPr>
-              <a:t>uic-laguna-xs2</a:t>
+              <a:t>uic-qwen36-35b-a3b</a:t>
             </a:r>
             <a:endParaRPr lang="en-US" sz="1600" dirty="0"/>
           </a:p>
@@ -4187,7 +4187,7 @@
                 <a:ea typeface="Calibri" pitchFamily="34" charset="-122"/>
                 <a:cs typeface="Calibri" pitchFamily="34" charset="-120"/>
               </a:rPr>
-              <a:t>49m</a:t>
+              <a:t>52m</a:t>
             </a:r>
             <a:endParaRPr lang="en-US" sz="1600" dirty="0"/>
           </a:p>
@@ -4290,7 +4290,7 @@
                 <a:ea typeface="Calibri" pitchFamily="34" charset="-122"/>
                 <a:cs typeface="Calibri" pitchFamily="34" charset="-120"/>
               </a:rPr>
-              <a:t>laguna-xs2 (33B.A3B MoE)</a:t>
+              <a:t>uic-laguna-xs2</a:t>
             </a:r>
             <a:endParaRPr lang="en-US" sz="1600" dirty="0"/>
           </a:p>
@@ -4329,7 +4329,7 @@
                 <a:ea typeface="Calibri" pitchFamily="34" charset="-122"/>
                 <a:cs typeface="Calibri" pitchFamily="34" charset="-120"/>
               </a:rPr>
-              <a:t>nVIDIA A100 ik_llama</a:t>
+              <a:t>nVIDIA A100 (MoE)</a:t>
             </a:r>
             <a:endParaRPr lang="en-US" sz="1600" dirty="0"/>
           </a:p>
@@ -4360,15 +4360,15 @@
               <a:buNone/>
             </a:pPr>
             <a:r>
-              <a:rPr lang="en-US" sz="1600" dirty="0">
-                <a:solidFill>
-                  <a:srgbClr val="14202E"/>
-                </a:solidFill>
-                <a:latin typeface="Calibri" pitchFamily="34" charset="0"/>
-                <a:ea typeface="Calibri" pitchFamily="34" charset="-122"/>
-                <a:cs typeface="Calibri" pitchFamily="34" charset="-120"/>
-              </a:rPr>
-              <a:t>27/30*</a:t>
+              <a:rPr lang="en-US" sz="1600" b="1" dirty="0">
+                <a:solidFill>
+                  <a:srgbClr val="3BA776"/>
+                </a:solidFill>
+                <a:latin typeface="Calibri" pitchFamily="34" charset="0"/>
+                <a:ea typeface="Calibri" pitchFamily="34" charset="-122"/>
+                <a:cs typeface="Calibri" pitchFamily="34" charset="-120"/>
+              </a:rPr>
+              <a:t>30/30</a:t>
             </a:r>
             <a:endParaRPr lang="en-US" sz="1600" dirty="0"/>
           </a:p>
@@ -4407,7 +4407,7 @@
                 <a:ea typeface="Calibri" pitchFamily="34" charset="-122"/>
                 <a:cs typeface="Calibri" pitchFamily="34" charset="-120"/>
               </a:rPr>
-              <a:t>56m</a:t>
+              <a:t>49m</a:t>
             </a:r>
             <a:endParaRPr lang="en-US" sz="1600" dirty="0"/>
           </a:p>
@@ -4510,7 +4510,7 @@
                 <a:ea typeface="Calibri" pitchFamily="34" charset="-122"/>
                 <a:cs typeface="Calibri" pitchFamily="34" charset="-120"/>
               </a:rPr>
-              <a:t>glm-5.2</a:t>
+              <a:t>laguna-xs2 (33B.A3B MoE)</a:t>
             </a:r>
             <a:endParaRPr lang="en-US" sz="1600" dirty="0"/>
           </a:p>
@@ -4549,7 +4549,7 @@
                 <a:ea typeface="Calibri" pitchFamily="34" charset="-122"/>
                 <a:cs typeface="Calibri" pitchFamily="34" charset="-120"/>
               </a:rPr>
-              <a:t>OpenRouter (paid)</a:t>
+              <a:t>nVIDIA A100 ik_llama</a:t>
             </a:r>
             <a:endParaRPr lang="en-US" sz="1600" dirty="0"/>
           </a:p>
@@ -4588,7 +4588,7 @@
                 <a:ea typeface="Calibri" pitchFamily="34" charset="-122"/>
                 <a:cs typeface="Calibri" pitchFamily="34" charset="-120"/>
               </a:rPr>
-              <a:t>29/30</a:t>
+              <a:t>27/30*</a:t>
             </a:r>
             <a:endParaRPr lang="en-US" sz="1600" dirty="0"/>
           </a:p>
@@ -4627,7 +4627,7 @@
                 <a:ea typeface="Calibri" pitchFamily="34" charset="-122"/>
                 <a:cs typeface="Calibri" pitchFamily="34" charset="-120"/>
               </a:rPr>
-              <a:t>44m</a:t>
+              <a:t>56m</a:t>
             </a:r>
             <a:endParaRPr lang="en-US" sz="1600" dirty="0"/>
           </a:p>
@@ -4730,7 +4730,7 @@
                 <a:ea typeface="Calibri" pitchFamily="34" charset="-122"/>
                 <a:cs typeface="Calibri" pitchFamily="34" charset="-120"/>
               </a:rPr>
-              <a:t>gemma4-31b</a:t>
+              <a:t>glm-5.2</a:t>
             </a:r>
             <a:endParaRPr lang="en-US" sz="1600" dirty="0"/>
           </a:p>
@@ -4769,7 +4769,7 @@
                 <a:ea typeface="Calibri" pitchFamily="34" charset="-122"/>
                 <a:cs typeface="Calibri" pitchFamily="34" charset="-120"/>
               </a:rPr>
-              <a:t>Intel PVC (1 tile)</a:t>
+              <a:t>OpenRouter (paid)</a:t>
             </a:r>
             <a:endParaRPr lang="en-US" sz="1600" dirty="0"/>
           </a:p>
@@ -4847,7 +4847,7 @@
                 <a:ea typeface="Calibri" pitchFamily="34" charset="-122"/>
                 <a:cs typeface="Calibri" pitchFamily="34" charset="-120"/>
               </a:rPr>
-              <a:t>3h01m</a:t>
+              <a:t>44m</a:t>
             </a:r>
             <a:endParaRPr lang="en-US" sz="1600" dirty="0"/>
           </a:p>
@@ -4950,7 +4950,7 @@
                 <a:ea typeface="Calibri" pitchFamily="34" charset="-122"/>
                 <a:cs typeface="Calibri" pitchFamily="34" charset="-120"/>
               </a:rPr>
-              <a:t>uic-ornith-9b (reasoning)</a:t>
+              <a:t>gemma4-31b</a:t>
             </a:r>
             <a:endParaRPr lang="en-US" sz="1600" dirty="0"/>
           </a:p>
@@ -4989,7 +4989,7 @@
                 <a:ea typeface="Calibri" pitchFamily="34" charset="-122"/>
                 <a:cs typeface="Calibri" pitchFamily="34" charset="-120"/>
               </a:rPr>
-              <a:t>nVIDIA A100 llama.cpp</a:t>
+              <a:t>Intel PVC (1 tile)</a:t>
             </a:r>
             <a:endParaRPr lang="en-US" sz="1600" dirty="0"/>
           </a:p>
@@ -5028,7 +5028,7 @@
                 <a:ea typeface="Calibri" pitchFamily="34" charset="-122"/>
                 <a:cs typeface="Calibri" pitchFamily="34" charset="-120"/>
               </a:rPr>
-              <a:t>28/30</a:t>
+              <a:t>29/30</a:t>
             </a:r>
             <a:endParaRPr lang="en-US" sz="1600" dirty="0"/>
           </a:p>
@@ -5067,7 +5067,7 @@
                 <a:ea typeface="Calibri" pitchFamily="34" charset="-122"/>
                 <a:cs typeface="Calibri" pitchFamily="34" charset="-120"/>
               </a:rPr>
-              <a:t>1h36m</a:t>
+              <a:t>3h01m</a:t>
             </a:r>
             <a:endParaRPr lang="en-US" sz="1600" dirty="0"/>
           </a:p>
@@ -5170,7 +5170,7 @@
                 <a:ea typeface="Calibri" pitchFamily="34" charset="-122"/>
                 <a:cs typeface="Calibri" pitchFamily="34" charset="-120"/>
               </a:rPr>
-              <a:t>gemma4-12b</a:t>
+              <a:t>uic-ornith-9b (reasoning)</a:t>
             </a:r>
             <a:endParaRPr lang="en-US" sz="1600" dirty="0"/>
           </a:p>
@@ -5209,7 +5209,7 @@
                 <a:ea typeface="Calibri" pitchFamily="34" charset="-122"/>
                 <a:cs typeface="Calibri" pitchFamily="34" charset="-120"/>
               </a:rPr>
-              <a:t>Intel PVC (1 tile)</a:t>
+              <a:t>nVIDIA A100 llama.cpp</a:t>
             </a:r>
             <a:endParaRPr lang="en-US" sz="1600" dirty="0"/>
           </a:p>
@@ -5287,7 +5287,7 @@
                 <a:ea typeface="Calibri" pitchFamily="34" charset="-122"/>
                 <a:cs typeface="Calibri" pitchFamily="34" charset="-120"/>
               </a:rPr>
-              <a:t>3h15m</a:t>
+              <a:t>1h36m</a:t>
             </a:r>
             <a:endParaRPr lang="en-US" sz="1600" dirty="0"/>
           </a:p>
@@ -5390,7 +5390,7 @@
                 <a:ea typeface="Calibri" pitchFamily="34" charset="-122"/>
                 <a:cs typeface="Calibri" pitchFamily="34" charset="-120"/>
               </a:rPr>
-              <a:t>devstral-small-2</a:t>
+              <a:t>gemma4-12b</a:t>
             </a:r>
             <a:endParaRPr lang="en-US" sz="1600" dirty="0"/>
           </a:p>
@@ -5507,6 +5507,226 @@
                 <a:ea typeface="Calibri" pitchFamily="34" charset="-122"/>
                 <a:cs typeface="Calibri" pitchFamily="34" charset="-120"/>
               </a:rPr>
+              <a:t>3h15m</a:t>
+            </a:r>
+            <a:endParaRPr lang="en-US" sz="1600" dirty="0"/>
+          </a:p>
+        </p:txBody>
+      </p:sp>
+      <p:sp>
+        <p:nvSpPr>
+          <p:cNvPr id="82" name="Shape 80"/>
+          <p:cNvSpPr/>
+          <p:nvPr/>
+        </p:nvSpPr>
+        <p:spPr>
+          <a:xfrm>
+            <a:off x="640080" y="6716268"/>
+            <a:ext cx="10908792" cy="379476"/>
+          </a:xfrm>
+          <a:prstGeom prst="rect">
+            <a:avLst/>
+          </a:prstGeom>
+          <a:solidFill>
+            <a:srgbClr val="FFFFFF"/>
+          </a:solidFill>
+          <a:ln w="6350">
+            <a:solidFill>
+              <a:srgbClr val="D8E2EE"/>
+            </a:solidFill>
+            <a:prstDash val="solid"/>
+          </a:ln>
+        </p:spPr>
+      </p:sp>
+      <p:sp>
+        <p:nvSpPr>
+          <p:cNvPr id="83" name="Text 81"/>
+          <p:cNvSpPr/>
+          <p:nvPr/>
+        </p:nvSpPr>
+        <p:spPr>
+          <a:xfrm>
+            <a:off x="731520" y="6716268"/>
+            <a:ext cx="548640" cy="379476"/>
+          </a:xfrm>
+          <a:prstGeom prst="rect">
+            <a:avLst/>
+          </a:prstGeom>
+          <a:noFill/>
+          <a:ln/>
+        </p:spPr>
+        <p:txBody>
+          <a:bodyPr wrap="square" rtlCol="0" anchor="ctr"/>
+          <a:lstStyle/>
+          <a:p>
+            <a:pPr indent="0" marL="0">
+              <a:buNone/>
+            </a:pPr>
+            <a:r>
+              <a:rPr lang="en-US" sz="1600" dirty="0">
+                <a:solidFill>
+                  <a:srgbClr val="55657A"/>
+                </a:solidFill>
+                <a:latin typeface="Calibri" pitchFamily="34" charset="0"/>
+                <a:ea typeface="Calibri" pitchFamily="34" charset="-122"/>
+                <a:cs typeface="Calibri" pitchFamily="34" charset="-120"/>
+              </a:rPr>
+              <a:t>13</a:t>
+            </a:r>
+            <a:endParaRPr lang="en-US" sz="1600" dirty="0"/>
+          </a:p>
+        </p:txBody>
+      </p:sp>
+      <p:sp>
+        <p:nvSpPr>
+          <p:cNvPr id="84" name="Text 82"/>
+          <p:cNvSpPr/>
+          <p:nvPr/>
+        </p:nvSpPr>
+        <p:spPr>
+          <a:xfrm>
+            <a:off x="1298448" y="6716268"/>
+            <a:ext cx="4023360" cy="379476"/>
+          </a:xfrm>
+          <a:prstGeom prst="rect">
+            <a:avLst/>
+          </a:prstGeom>
+          <a:noFill/>
+          <a:ln/>
+        </p:spPr>
+        <p:txBody>
+          <a:bodyPr wrap="square" rtlCol="0" anchor="ctr"/>
+          <a:lstStyle/>
+          <a:p>
+            <a:pPr indent="0" marL="0">
+              <a:buNone/>
+            </a:pPr>
+            <a:r>
+              <a:rPr lang="en-US" sz="1600" dirty="0">
+                <a:solidFill>
+                  <a:srgbClr val="14202E"/>
+                </a:solidFill>
+                <a:latin typeface="Calibri" pitchFamily="34" charset="0"/>
+                <a:ea typeface="Calibri" pitchFamily="34" charset="-122"/>
+                <a:cs typeface="Calibri" pitchFamily="34" charset="-120"/>
+              </a:rPr>
+              <a:t>devstral-small-2</a:t>
+            </a:r>
+            <a:endParaRPr lang="en-US" sz="1600" dirty="0"/>
+          </a:p>
+        </p:txBody>
+      </p:sp>
+      <p:sp>
+        <p:nvSpPr>
+          <p:cNvPr id="85" name="Text 83"/>
+          <p:cNvSpPr/>
+          <p:nvPr/>
+        </p:nvSpPr>
+        <p:spPr>
+          <a:xfrm>
+            <a:off x="5349240" y="6716268"/>
+            <a:ext cx="3200400" cy="379476"/>
+          </a:xfrm>
+          <a:prstGeom prst="rect">
+            <a:avLst/>
+          </a:prstGeom>
+          <a:noFill/>
+          <a:ln/>
+        </p:spPr>
+        <p:txBody>
+          <a:bodyPr wrap="square" rtlCol="0" anchor="ctr"/>
+          <a:lstStyle/>
+          <a:p>
+            <a:pPr indent="0" marL="0">
+              <a:buNone/>
+            </a:pPr>
+            <a:r>
+              <a:rPr lang="en-US" sz="1600" dirty="0">
+                <a:solidFill>
+                  <a:srgbClr val="33414F"/>
+                </a:solidFill>
+                <a:latin typeface="Calibri" pitchFamily="34" charset="0"/>
+                <a:ea typeface="Calibri" pitchFamily="34" charset="-122"/>
+                <a:cs typeface="Calibri" pitchFamily="34" charset="-120"/>
+              </a:rPr>
+              <a:t>Intel PVC (1 tile)</a:t>
+            </a:r>
+            <a:endParaRPr lang="en-US" sz="1600" dirty="0"/>
+          </a:p>
+        </p:txBody>
+      </p:sp>
+      <p:sp>
+        <p:nvSpPr>
+          <p:cNvPr id="86" name="Text 84"/>
+          <p:cNvSpPr/>
+          <p:nvPr/>
+        </p:nvSpPr>
+        <p:spPr>
+          <a:xfrm>
+            <a:off x="8595360" y="6716268"/>
+            <a:ext cx="1463040" cy="379476"/>
+          </a:xfrm>
+          <a:prstGeom prst="rect">
+            <a:avLst/>
+          </a:prstGeom>
+          <a:noFill/>
+          <a:ln/>
+        </p:spPr>
+        <p:txBody>
+          <a:bodyPr wrap="square" rtlCol="0" anchor="ctr"/>
+          <a:lstStyle/>
+          <a:p>
+            <a:pPr algn="ctr" indent="0" marL="0">
+              <a:buNone/>
+            </a:pPr>
+            <a:r>
+              <a:rPr lang="en-US" sz="1600" dirty="0">
+                <a:solidFill>
+                  <a:srgbClr val="14202E"/>
+                </a:solidFill>
+                <a:latin typeface="Calibri" pitchFamily="34" charset="0"/>
+                <a:ea typeface="Calibri" pitchFamily="34" charset="-122"/>
+                <a:cs typeface="Calibri" pitchFamily="34" charset="-120"/>
+              </a:rPr>
+              <a:t>28/30</a:t>
+            </a:r>
+            <a:endParaRPr lang="en-US" sz="1600" dirty="0"/>
+          </a:p>
+        </p:txBody>
+      </p:sp>
+      <p:sp>
+        <p:nvSpPr>
+          <p:cNvPr id="87" name="Text 85"/>
+          <p:cNvSpPr/>
+          <p:nvPr/>
+        </p:nvSpPr>
+        <p:spPr>
+          <a:xfrm>
+            <a:off x="10104120" y="6716268"/>
+            <a:ext cx="1325880" cy="379476"/>
+          </a:xfrm>
+          <a:prstGeom prst="rect">
+            <a:avLst/>
+          </a:prstGeom>
+          <a:noFill/>
+          <a:ln/>
+        </p:spPr>
+        <p:txBody>
+          <a:bodyPr wrap="square" rtlCol="0" anchor="ctr"/>
+          <a:lstStyle/>
+          <a:p>
+            <a:pPr algn="l" indent="0" marL="0">
+              <a:buNone/>
+            </a:pPr>
+            <a:r>
+              <a:rPr lang="en-US" sz="1600" dirty="0">
+                <a:solidFill>
+                  <a:srgbClr val="55657A"/>
+                </a:solidFill>
+                <a:latin typeface="Calibri" pitchFamily="34" charset="0"/>
+                <a:ea typeface="Calibri" pitchFamily="34" charset="-122"/>
+                <a:cs typeface="Calibri" pitchFamily="34" charset="-120"/>
+              </a:rPr>
               <a:t>1h27m</a:t>
             </a:r>
             <a:endParaRPr lang="en-US" sz="1600" dirty="0"/>
@@ -5515,7 +5735,7 @@
       </p:sp>
       <p:sp>
         <p:nvSpPr>
-          <p:cNvPr id="82" name="Text 80"/>
+          <p:cNvPr id="88" name="Text 86"/>
           <p:cNvSpPr/>
           <p:nvPr/>
         </p:nvSpPr>
@@ -5656,7 +5876,7 @@
                 <a:ea typeface="Georgia" pitchFamily="34" charset="-122"/>
                 <a:cs typeface="Georgia" pitchFamily="34" charset="-120"/>
               </a:rPr>
-              <a:t>All 24 lanes — ranks 13–24</a:t>
+              <a:t>All 26 lanes — ranks 14–26</a:t>
             </a:r>
             <a:endParaRPr lang="en-US" sz="4000" dirty="0"/>
           </a:p>
@@ -5935,7 +6155,7 @@
                 <a:ea typeface="Calibri" pitchFamily="34" charset="-122"/>
                 <a:cs typeface="Calibri" pitchFamily="34" charset="-120"/>
               </a:rPr>
-              <a:t>13</a:t>
+              <a:t>14</a:t>
             </a:r>
             <a:endParaRPr lang="en-US" sz="1600" dirty="0"/>
           </a:p>
@@ -6155,7 +6375,7 @@
                 <a:ea typeface="Calibri" pitchFamily="34" charset="-122"/>
                 <a:cs typeface="Calibri" pitchFamily="34" charset="-120"/>
               </a:rPr>
-              <a:t>14</a:t>
+              <a:t>15</a:t>
             </a:r>
             <a:endParaRPr lang="en-US" sz="1600" dirty="0"/>
           </a:p>
@@ -6375,7 +6595,7 @@
                 <a:ea typeface="Calibri" pitchFamily="34" charset="-122"/>
                 <a:cs typeface="Calibri" pitchFamily="34" charset="-120"/>
               </a:rPr>
-              <a:t>15</a:t>
+              <a:t>16</a:t>
             </a:r>
             <a:endParaRPr lang="en-US" sz="1600" dirty="0"/>
           </a:p>
@@ -6414,7 +6634,7 @@
                 <a:ea typeface="Calibri" pitchFamily="34" charset="-122"/>
                 <a:cs typeface="Calibri" pitchFamily="34" charset="-120"/>
               </a:rPr>
-              <a:t>uic-gemma4-26b-q8</a:t>
+              <a:t>laguna-s-2.1 (48L MoE)</a:t>
             </a:r>
             <a:endParaRPr lang="en-US" sz="1600" dirty="0"/>
           </a:p>
@@ -6453,7 +6673,7 @@
                 <a:ea typeface="Calibri" pitchFamily="34" charset="-122"/>
                 <a:cs typeface="Calibri" pitchFamily="34" charset="-120"/>
               </a:rPr>
-              <a:t>nVIDIA A100 (Q8)</a:t>
+              <a:t>local dgx ik_llama · chicago-2</a:t>
             </a:r>
             <a:endParaRPr lang="en-US" sz="1600" dirty="0"/>
           </a:p>
@@ -6492,7 +6712,7 @@
                 <a:ea typeface="Calibri" pitchFamily="34" charset="-122"/>
                 <a:cs typeface="Calibri" pitchFamily="34" charset="-120"/>
               </a:rPr>
-              <a:t>24/30</a:t>
+              <a:t>26/30</a:t>
             </a:r>
             <a:endParaRPr lang="en-US" sz="1600" dirty="0"/>
           </a:p>
@@ -6531,7 +6751,7 @@
                 <a:ea typeface="Calibri" pitchFamily="34" charset="-122"/>
                 <a:cs typeface="Calibri" pitchFamily="34" charset="-120"/>
               </a:rPr>
-              <a:t>1h40m</a:t>
+              <a:t>2h17m</a:t>
             </a:r>
             <a:endParaRPr lang="en-US" sz="1600" dirty="0"/>
           </a:p>
@@ -6595,7 +6815,7 @@
                 <a:ea typeface="Calibri" pitchFamily="34" charset="-122"/>
                 <a:cs typeface="Calibri" pitchFamily="34" charset="-120"/>
               </a:rPr>
-              <a:t>16</a:t>
+              <a:t>17</a:t>
             </a:r>
             <a:endParaRPr lang="en-US" sz="1600" dirty="0"/>
           </a:p>
@@ -6634,7 +6854,7 @@
                 <a:ea typeface="Calibri" pitchFamily="34" charset="-122"/>
                 <a:cs typeface="Calibri" pitchFamily="34" charset="-120"/>
               </a:rPr>
-              <a:t>devstral2-24b</a:t>
+              <a:t>uic-gemma4-26b-q8</a:t>
             </a:r>
             <a:endParaRPr lang="en-US" sz="1600" dirty="0"/>
           </a:p>
@@ -6673,7 +6893,7 @@
                 <a:ea typeface="Calibri" pitchFamily="34" charset="-122"/>
                 <a:cs typeface="Calibri" pitchFamily="34" charset="-120"/>
               </a:rPr>
-              <a:t>spark (ollama)</a:t>
+              <a:t>nVIDIA A100 (Q8)</a:t>
             </a:r>
             <a:endParaRPr lang="en-US" sz="1600" dirty="0"/>
           </a:p>
@@ -6751,7 +6971,7 @@
                 <a:ea typeface="Calibri" pitchFamily="34" charset="-122"/>
                 <a:cs typeface="Calibri" pitchFamily="34" charset="-120"/>
               </a:rPr>
-              <a:t>2h14m</a:t>
+              <a:t>1h40m</a:t>
             </a:r>
             <a:endParaRPr lang="en-US" sz="1600" dirty="0"/>
           </a:p>
@@ -6815,7 +7035,7 @@
                 <a:ea typeface="Calibri" pitchFamily="34" charset="-122"/>
                 <a:cs typeface="Calibri" pitchFamily="34" charset="-120"/>
               </a:rPr>
-              <a:t>17</a:t>
+              <a:t>18</a:t>
             </a:r>
             <a:endParaRPr lang="en-US" sz="1600" dirty="0"/>
           </a:p>
@@ -6854,7 +7074,7 @@
                 <a:ea typeface="Calibri" pitchFamily="34" charset="-122"/>
                 <a:cs typeface="Calibri" pitchFamily="34" charset="-120"/>
               </a:rPr>
-              <a:t>uic-ornith-35b</a:t>
+              <a:t>devstral2-24b</a:t>
             </a:r>
             <a:endParaRPr lang="en-US" sz="1600" dirty="0"/>
           </a:p>
@@ -6893,7 +7113,7 @@
                 <a:ea typeface="Calibri" pitchFamily="34" charset="-122"/>
                 <a:cs typeface="Calibri" pitchFamily="34" charset="-120"/>
               </a:rPr>
-              <a:t>nVIDIA A100</a:t>
+              <a:t>spark (ollama)</a:t>
             </a:r>
             <a:endParaRPr lang="en-US" sz="1600" dirty="0"/>
           </a:p>
@@ -6932,7 +7152,7 @@
                 <a:ea typeface="Calibri" pitchFamily="34" charset="-122"/>
                 <a:cs typeface="Calibri" pitchFamily="34" charset="-120"/>
               </a:rPr>
-              <a:t>23/30</a:t>
+              <a:t>24/30</a:t>
             </a:r>
             <a:endParaRPr lang="en-US" sz="1600" dirty="0"/>
           </a:p>
@@ -6971,7 +7191,7 @@
                 <a:ea typeface="Calibri" pitchFamily="34" charset="-122"/>
                 <a:cs typeface="Calibri" pitchFamily="34" charset="-120"/>
               </a:rPr>
-              <a:t>1h29m</a:t>
+              <a:t>2h14m</a:t>
             </a:r>
             <a:endParaRPr lang="en-US" sz="1600" dirty="0"/>
           </a:p>
@@ -7035,7 +7255,7 @@
                 <a:ea typeface="Calibri" pitchFamily="34" charset="-122"/>
                 <a:cs typeface="Calibri" pitchFamily="34" charset="-120"/>
               </a:rPr>
-              <a:t>18</a:t>
+              <a:t>19</a:t>
             </a:r>
             <a:endParaRPr lang="en-US" sz="1600" dirty="0"/>
           </a:p>
@@ -7074,7 +7294,7 @@
                 <a:ea typeface="Calibri" pitchFamily="34" charset="-122"/>
                 <a:cs typeface="Calibri" pitchFamily="34" charset="-120"/>
               </a:rPr>
-              <a:t>nemotron-3-ultra 550B</a:t>
+              <a:t>uic-ornith-35b</a:t>
             </a:r>
             <a:endParaRPr lang="en-US" sz="1600" dirty="0"/>
           </a:p>
@@ -7113,7 +7333,7 @@
                 <a:ea typeface="Calibri" pitchFamily="34" charset="-122"/>
                 <a:cs typeface="Calibri" pitchFamily="34" charset="-120"/>
               </a:rPr>
-              <a:t>local dgx (rbh101)</a:t>
+              <a:t>nVIDIA A100</a:t>
             </a:r>
             <a:endParaRPr lang="en-US" sz="1600" dirty="0"/>
           </a:p>
@@ -7152,7 +7372,7 @@
                 <a:ea typeface="Calibri" pitchFamily="34" charset="-122"/>
                 <a:cs typeface="Calibri" pitchFamily="34" charset="-120"/>
               </a:rPr>
-              <a:t>22/26</a:t>
+              <a:t>23/30</a:t>
             </a:r>
             <a:endParaRPr lang="en-US" sz="1600" dirty="0"/>
           </a:p>
@@ -7191,7 +7411,7 @@
                 <a:ea typeface="Calibri" pitchFamily="34" charset="-122"/>
                 <a:cs typeface="Calibri" pitchFamily="34" charset="-120"/>
               </a:rPr>
-              <a:t>hung@P27</a:t>
+              <a:t>1h29m</a:t>
             </a:r>
             <a:endParaRPr lang="en-US" sz="1600" dirty="0"/>
           </a:p>
@@ -7255,7 +7475,7 @@
                 <a:ea typeface="Calibri" pitchFamily="34" charset="-122"/>
                 <a:cs typeface="Calibri" pitchFamily="34" charset="-120"/>
               </a:rPr>
-              <a:t>19</a:t>
+              <a:t>20</a:t>
             </a:r>
             <a:endParaRPr lang="en-US" sz="1600" dirty="0"/>
           </a:p>
@@ -7294,7 +7514,7 @@
                 <a:ea typeface="Calibri" pitchFamily="34" charset="-122"/>
                 <a:cs typeface="Calibri" pitchFamily="34" charset="-120"/>
               </a:rPr>
-              <a:t>qwen3-14b</a:t>
+              <a:t>nemotron-3-ultra 550B</a:t>
             </a:r>
             <a:endParaRPr lang="en-US" sz="1600" dirty="0"/>
           </a:p>
@@ -7333,7 +7553,7 @@
                 <a:ea typeface="Calibri" pitchFamily="34" charset="-122"/>
                 <a:cs typeface="Calibri" pitchFamily="34" charset="-120"/>
               </a:rPr>
-              <a:t>spark (ollama)</a:t>
+              <a:t>local dgx (rbh101)</a:t>
             </a:r>
             <a:endParaRPr lang="en-US" sz="1600" dirty="0"/>
           </a:p>
@@ -7372,7 +7592,7 @@
                 <a:ea typeface="Calibri" pitchFamily="34" charset="-122"/>
                 <a:cs typeface="Calibri" pitchFamily="34" charset="-120"/>
               </a:rPr>
-              <a:t>20/28</a:t>
+              <a:t>22/26</a:t>
             </a:r>
             <a:endParaRPr lang="en-US" sz="1600" dirty="0"/>
           </a:p>
@@ -7411,7 +7631,7 @@
                 <a:ea typeface="Calibri" pitchFamily="34" charset="-122"/>
                 <a:cs typeface="Calibri" pitchFamily="34" charset="-120"/>
               </a:rPr>
-              <a:t>4h41m</a:t>
+              <a:t>hung@P27</a:t>
             </a:r>
             <a:endParaRPr lang="en-US" sz="1600" dirty="0"/>
           </a:p>
@@ -7475,7 +7695,7 @@
                 <a:ea typeface="Calibri" pitchFamily="34" charset="-122"/>
                 <a:cs typeface="Calibri" pitchFamily="34" charset="-120"/>
               </a:rPr>
-              <a:t>20</a:t>
+              <a:t>21</a:t>
             </a:r>
             <a:endParaRPr lang="en-US" sz="1600" dirty="0"/>
           </a:p>
@@ -7514,7 +7734,7 @@
                 <a:ea typeface="Calibri" pitchFamily="34" charset="-122"/>
                 <a:cs typeface="Calibri" pitchFamily="34" charset="-120"/>
               </a:rPr>
-              <a:t>gemma4-e4b</a:t>
+              <a:t>qwen3-14b</a:t>
             </a:r>
             <a:endParaRPr lang="en-US" sz="1600" dirty="0"/>
           </a:p>
@@ -7553,7 +7773,7 @@
                 <a:ea typeface="Calibri" pitchFamily="34" charset="-122"/>
                 <a:cs typeface="Calibri" pitchFamily="34" charset="-120"/>
               </a:rPr>
-              <a:t>Intel PVC (1 tile)</a:t>
+              <a:t>spark (ollama)</a:t>
             </a:r>
             <a:endParaRPr lang="en-US" sz="1600" dirty="0"/>
           </a:p>
@@ -7592,7 +7812,7 @@
                 <a:ea typeface="Calibri" pitchFamily="34" charset="-122"/>
                 <a:cs typeface="Calibri" pitchFamily="34" charset="-120"/>
               </a:rPr>
-              <a:t>20/30</a:t>
+              <a:t>20/28</a:t>
             </a:r>
             <a:endParaRPr lang="en-US" sz="1600" dirty="0"/>
           </a:p>
@@ -7631,7 +7851,7 @@
                 <a:ea typeface="Calibri" pitchFamily="34" charset="-122"/>
                 <a:cs typeface="Calibri" pitchFamily="34" charset="-120"/>
               </a:rPr>
-              <a:t>1h39m</a:t>
+              <a:t>4h41m</a:t>
             </a:r>
             <a:endParaRPr lang="en-US" sz="1600" dirty="0"/>
           </a:p>
@@ -7695,7 +7915,7 @@
                 <a:ea typeface="Calibri" pitchFamily="34" charset="-122"/>
                 <a:cs typeface="Calibri" pitchFamily="34" charset="-120"/>
               </a:rPr>
-              <a:t>21</a:t>
+              <a:t>22</a:t>
             </a:r>
             <a:endParaRPr lang="en-US" sz="1600" dirty="0"/>
           </a:p>
@@ -7734,7 +7954,7 @@
                 <a:ea typeface="Calibri" pitchFamily="34" charset="-122"/>
                 <a:cs typeface="Calibri" pitchFamily="34" charset="-120"/>
               </a:rPr>
-              <a:t>gemma4-e2b</a:t>
+              <a:t>gemma4-e4b</a:t>
             </a:r>
             <a:endParaRPr lang="en-US" sz="1600" dirty="0"/>
           </a:p>
@@ -7851,7 +8071,7 @@
                 <a:ea typeface="Calibri" pitchFamily="34" charset="-122"/>
                 <a:cs typeface="Calibri" pitchFamily="34" charset="-120"/>
               </a:rPr>
-              <a:t>1h02m</a:t>
+              <a:t>1h39m</a:t>
             </a:r>
             <a:endParaRPr lang="en-US" sz="1600" dirty="0"/>
           </a:p>
@@ -7915,7 +8135,7 @@
                 <a:ea typeface="Calibri" pitchFamily="34" charset="-122"/>
                 <a:cs typeface="Calibri" pitchFamily="34" charset="-120"/>
               </a:rPr>
-              <a:t>22</a:t>
+              <a:t>23</a:t>
             </a:r>
             <a:endParaRPr lang="en-US" sz="1600" dirty="0"/>
           </a:p>
@@ -7954,7 +8174,7 @@
                 <a:ea typeface="Calibri" pitchFamily="34" charset="-122"/>
                 <a:cs typeface="Calibri" pitchFamily="34" charset="-120"/>
               </a:rPr>
-              <a:t>nemotron-3-nano 30B</a:t>
+              <a:t>gemma4-e2b</a:t>
             </a:r>
             <a:endParaRPr lang="en-US" sz="1600" dirty="0"/>
           </a:p>
@@ -7993,7 +8213,7 @@
                 <a:ea typeface="Calibri" pitchFamily="34" charset="-122"/>
                 <a:cs typeface="Calibri" pitchFamily="34" charset="-120"/>
               </a:rPr>
-              <a:t>spark (ollama)</a:t>
+              <a:t>Intel PVC (1 tile)</a:t>
             </a:r>
             <a:endParaRPr lang="en-US" sz="1600" dirty="0"/>
           </a:p>
@@ -8032,7 +8252,7 @@
                 <a:ea typeface="Calibri" pitchFamily="34" charset="-122"/>
                 <a:cs typeface="Calibri" pitchFamily="34" charset="-120"/>
               </a:rPr>
-              <a:t>19/30</a:t>
+              <a:t>20/30</a:t>
             </a:r>
             <a:endParaRPr lang="en-US" sz="1600" dirty="0"/>
           </a:p>
@@ -8071,7 +8291,7 @@
                 <a:ea typeface="Calibri" pitchFamily="34" charset="-122"/>
                 <a:cs typeface="Calibri" pitchFamily="34" charset="-120"/>
               </a:rPr>
-              <a:t>7h36m</a:t>
+              <a:t>1h02m</a:t>
             </a:r>
             <a:endParaRPr lang="en-US" sz="1600" dirty="0"/>
           </a:p>
@@ -8135,7 +8355,7 @@
                 <a:ea typeface="Calibri" pitchFamily="34" charset="-122"/>
                 <a:cs typeface="Calibri" pitchFamily="34" charset="-120"/>
               </a:rPr>
-              <a:t>23</a:t>
+              <a:t>24</a:t>
             </a:r>
             <a:endParaRPr lang="en-US" sz="1600" dirty="0"/>
           </a:p>
@@ -8174,7 +8394,7 @@
                 <a:ea typeface="Calibri" pitchFamily="34" charset="-122"/>
                 <a:cs typeface="Calibri" pitchFamily="34" charset="-120"/>
               </a:rPr>
-              <a:t>llama70</a:t>
+              <a:t>nemotron-3-nano 30B</a:t>
             </a:r>
             <a:endParaRPr lang="en-US" sz="1600" dirty="0"/>
           </a:p>
@@ -8213,7 +8433,7 @@
                 <a:ea typeface="Calibri" pitchFamily="34" charset="-122"/>
                 <a:cs typeface="Calibri" pitchFamily="34" charset="-120"/>
               </a:rPr>
-              <a:t>local dgx</a:t>
+              <a:t>spark (ollama)</a:t>
             </a:r>
             <a:endParaRPr lang="en-US" sz="1600" dirty="0"/>
           </a:p>
@@ -8252,7 +8472,7 @@
                 <a:ea typeface="Calibri" pitchFamily="34" charset="-122"/>
                 <a:cs typeface="Calibri" pitchFamily="34" charset="-120"/>
               </a:rPr>
-              <a:t>18/29</a:t>
+              <a:t>19/30</a:t>
             </a:r>
             <a:endParaRPr lang="en-US" sz="1600" dirty="0"/>
           </a:p>
@@ -8291,7 +8511,7 @@
                 <a:ea typeface="Calibri" pitchFamily="34" charset="-122"/>
                 <a:cs typeface="Calibri" pitchFamily="34" charset="-120"/>
               </a:rPr>
-              <a:t>7h16m</a:t>
+              <a:t>7h36m</a:t>
             </a:r>
             <a:endParaRPr lang="en-US" sz="1600" dirty="0"/>
           </a:p>
@@ -8355,7 +8575,7 @@
                 <a:ea typeface="Calibri" pitchFamily="34" charset="-122"/>
                 <a:cs typeface="Calibri" pitchFamily="34" charset="-120"/>
               </a:rPr>
-              <a:t>24</a:t>
+              <a:t>25</a:t>
             </a:r>
             <a:endParaRPr lang="en-US" sz="1600" dirty="0"/>
           </a:p>
@@ -8394,7 +8614,7 @@
                 <a:ea typeface="Calibri" pitchFamily="34" charset="-122"/>
                 <a:cs typeface="Calibri" pitchFamily="34" charset="-120"/>
               </a:rPr>
-              <a:t>nemotron3 33B (Omni)</a:t>
+              <a:t>llama70 (retired 07-22)</a:t>
             </a:r>
             <a:endParaRPr lang="en-US" sz="1600" dirty="0"/>
           </a:p>
@@ -8433,7 +8653,7 @@
                 <a:ea typeface="Calibri" pitchFamily="34" charset="-122"/>
                 <a:cs typeface="Calibri" pitchFamily="34" charset="-120"/>
               </a:rPr>
-              <a:t>spark (ollama)</a:t>
+              <a:t>local dgx</a:t>
             </a:r>
             <a:endParaRPr lang="en-US" sz="1600" dirty="0"/>
           </a:p>
@@ -8472,7 +8692,7 @@
                 <a:ea typeface="Calibri" pitchFamily="34" charset="-122"/>
                 <a:cs typeface="Calibri" pitchFamily="34" charset="-120"/>
               </a:rPr>
-              <a:t>16/30</a:t>
+              <a:t>18/29</a:t>
             </a:r>
             <a:endParaRPr lang="en-US" sz="1600" dirty="0"/>
           </a:p>
@@ -8511,6 +8731,226 @@
                 <a:ea typeface="Calibri" pitchFamily="34" charset="-122"/>
                 <a:cs typeface="Calibri" pitchFamily="34" charset="-120"/>
               </a:rPr>
+              <a:t>7h16m</a:t>
+            </a:r>
+            <a:endParaRPr lang="en-US" sz="1600" dirty="0"/>
+          </a:p>
+        </p:txBody>
+      </p:sp>
+      <p:sp>
+        <p:nvSpPr>
+          <p:cNvPr id="82" name="Shape 80"/>
+          <p:cNvSpPr/>
+          <p:nvPr/>
+        </p:nvSpPr>
+        <p:spPr>
+          <a:xfrm>
+            <a:off x="640080" y="6716268"/>
+            <a:ext cx="10908792" cy="379476"/>
+          </a:xfrm>
+          <a:prstGeom prst="rect">
+            <a:avLst/>
+          </a:prstGeom>
+          <a:solidFill>
+            <a:srgbClr val="FFFFFF"/>
+          </a:solidFill>
+          <a:ln w="6350">
+            <a:solidFill>
+              <a:srgbClr val="D8E2EE"/>
+            </a:solidFill>
+            <a:prstDash val="solid"/>
+          </a:ln>
+        </p:spPr>
+      </p:sp>
+      <p:sp>
+        <p:nvSpPr>
+          <p:cNvPr id="83" name="Text 81"/>
+          <p:cNvSpPr/>
+          <p:nvPr/>
+        </p:nvSpPr>
+        <p:spPr>
+          <a:xfrm>
+            <a:off x="731520" y="6716268"/>
+            <a:ext cx="548640" cy="379476"/>
+          </a:xfrm>
+          <a:prstGeom prst="rect">
+            <a:avLst/>
+          </a:prstGeom>
+          <a:noFill/>
+          <a:ln/>
+        </p:spPr>
+        <p:txBody>
+          <a:bodyPr wrap="square" rtlCol="0" anchor="ctr"/>
+          <a:lstStyle/>
+          <a:p>
+            <a:pPr indent="0" marL="0">
+              <a:buNone/>
+            </a:pPr>
+            <a:r>
+              <a:rPr lang="en-US" sz="1600" dirty="0">
+                <a:solidFill>
+                  <a:srgbClr val="55657A"/>
+                </a:solidFill>
+                <a:latin typeface="Calibri" pitchFamily="34" charset="0"/>
+                <a:ea typeface="Calibri" pitchFamily="34" charset="-122"/>
+                <a:cs typeface="Calibri" pitchFamily="34" charset="-120"/>
+              </a:rPr>
+              <a:t>26</a:t>
+            </a:r>
+            <a:endParaRPr lang="en-US" sz="1600" dirty="0"/>
+          </a:p>
+        </p:txBody>
+      </p:sp>
+      <p:sp>
+        <p:nvSpPr>
+          <p:cNvPr id="84" name="Text 82"/>
+          <p:cNvSpPr/>
+          <p:nvPr/>
+        </p:nvSpPr>
+        <p:spPr>
+          <a:xfrm>
+            <a:off x="1298448" y="6716268"/>
+            <a:ext cx="4023360" cy="379476"/>
+          </a:xfrm>
+          <a:prstGeom prst="rect">
+            <a:avLst/>
+          </a:prstGeom>
+          <a:noFill/>
+          <a:ln/>
+        </p:spPr>
+        <p:txBody>
+          <a:bodyPr wrap="square" rtlCol="0" anchor="ctr"/>
+          <a:lstStyle/>
+          <a:p>
+            <a:pPr indent="0" marL="0">
+              <a:buNone/>
+            </a:pPr>
+            <a:r>
+              <a:rPr lang="en-US" sz="1600" dirty="0">
+                <a:solidFill>
+                  <a:srgbClr val="14202E"/>
+                </a:solidFill>
+                <a:latin typeface="Calibri" pitchFamily="34" charset="0"/>
+                <a:ea typeface="Calibri" pitchFamily="34" charset="-122"/>
+                <a:cs typeface="Calibri" pitchFamily="34" charset="-120"/>
+              </a:rPr>
+              <a:t>nemotron3 33B (Omni)</a:t>
+            </a:r>
+            <a:endParaRPr lang="en-US" sz="1600" dirty="0"/>
+          </a:p>
+        </p:txBody>
+      </p:sp>
+      <p:sp>
+        <p:nvSpPr>
+          <p:cNvPr id="85" name="Text 83"/>
+          <p:cNvSpPr/>
+          <p:nvPr/>
+        </p:nvSpPr>
+        <p:spPr>
+          <a:xfrm>
+            <a:off x="5349240" y="6716268"/>
+            <a:ext cx="3200400" cy="379476"/>
+          </a:xfrm>
+          <a:prstGeom prst="rect">
+            <a:avLst/>
+          </a:prstGeom>
+          <a:noFill/>
+          <a:ln/>
+        </p:spPr>
+        <p:txBody>
+          <a:bodyPr wrap="square" rtlCol="0" anchor="ctr"/>
+          <a:lstStyle/>
+          <a:p>
+            <a:pPr indent="0" marL="0">
+              <a:buNone/>
+            </a:pPr>
+            <a:r>
+              <a:rPr lang="en-US" sz="1600" dirty="0">
+                <a:solidFill>
+                  <a:srgbClr val="33414F"/>
+                </a:solidFill>
+                <a:latin typeface="Calibri" pitchFamily="34" charset="0"/>
+                <a:ea typeface="Calibri" pitchFamily="34" charset="-122"/>
+                <a:cs typeface="Calibri" pitchFamily="34" charset="-120"/>
+              </a:rPr>
+              <a:t>spark (ollama)</a:t>
+            </a:r>
+            <a:endParaRPr lang="en-US" sz="1600" dirty="0"/>
+          </a:p>
+        </p:txBody>
+      </p:sp>
+      <p:sp>
+        <p:nvSpPr>
+          <p:cNvPr id="86" name="Text 84"/>
+          <p:cNvSpPr/>
+          <p:nvPr/>
+        </p:nvSpPr>
+        <p:spPr>
+          <a:xfrm>
+            <a:off x="8595360" y="6716268"/>
+            <a:ext cx="1463040" cy="379476"/>
+          </a:xfrm>
+          <a:prstGeom prst="rect">
+            <a:avLst/>
+          </a:prstGeom>
+          <a:noFill/>
+          <a:ln/>
+        </p:spPr>
+        <p:txBody>
+          <a:bodyPr wrap="square" rtlCol="0" anchor="ctr"/>
+          <a:lstStyle/>
+          <a:p>
+            <a:pPr algn="ctr" indent="0" marL="0">
+              <a:buNone/>
+            </a:pPr>
+            <a:r>
+              <a:rPr lang="en-US" sz="1600" dirty="0">
+                <a:solidFill>
+                  <a:srgbClr val="14202E"/>
+                </a:solidFill>
+                <a:latin typeface="Calibri" pitchFamily="34" charset="0"/>
+                <a:ea typeface="Calibri" pitchFamily="34" charset="-122"/>
+                <a:cs typeface="Calibri" pitchFamily="34" charset="-120"/>
+              </a:rPr>
+              <a:t>16/30</a:t>
+            </a:r>
+            <a:endParaRPr lang="en-US" sz="1600" dirty="0"/>
+          </a:p>
+        </p:txBody>
+      </p:sp>
+      <p:sp>
+        <p:nvSpPr>
+          <p:cNvPr id="87" name="Text 85"/>
+          <p:cNvSpPr/>
+          <p:nvPr/>
+        </p:nvSpPr>
+        <p:spPr>
+          <a:xfrm>
+            <a:off x="10104120" y="6716268"/>
+            <a:ext cx="1325880" cy="379476"/>
+          </a:xfrm>
+          <a:prstGeom prst="rect">
+            <a:avLst/>
+          </a:prstGeom>
+          <a:noFill/>
+          <a:ln/>
+        </p:spPr>
+        <p:txBody>
+          <a:bodyPr wrap="square" rtlCol="0" anchor="ctr"/>
+          <a:lstStyle/>
+          <a:p>
+            <a:pPr algn="l" indent="0" marL="0">
+              <a:buNone/>
+            </a:pPr>
+            <a:r>
+              <a:rPr lang="en-US" sz="1600" dirty="0">
+                <a:solidFill>
+                  <a:srgbClr val="55657A"/>
+                </a:solidFill>
+                <a:latin typeface="Calibri" pitchFamily="34" charset="0"/>
+                <a:ea typeface="Calibri" pitchFamily="34" charset="-122"/>
+                <a:cs typeface="Calibri" pitchFamily="34" charset="-120"/>
+              </a:rPr>
               <a:t>7h31m</a:t>
             </a:r>
             <a:endParaRPr lang="en-US" sz="1600" dirty="0"/>
@@ -8519,7 +8959,7 @@
       </p:sp>
       <p:sp>
         <p:nvSpPr>
-          <p:cNvPr id="82" name="Text 80"/>
+          <p:cNvPr id="88" name="Text 86"/>
           <p:cNvSpPr/>
           <p:nvPr/>
         </p:nvSpPr>
@@ -13723,7 +14163,7 @@
                 <a:ea typeface="Georgia" pitchFamily="34" charset="-122"/>
                 <a:cs typeface="Georgia" pitchFamily="34" charset="-120"/>
               </a:rPr>
-              <a:t>Seven lanes reached a clean 30/30</a:t>
+              <a:t>Eight lanes reached a clean 30/30</a:t>
             </a:r>
             <a:endParaRPr lang="en-US" sz="4000" dirty="0"/>
           </a:p>
@@ -14184,7 +14624,7 @@
                 <a:ea typeface="Calibri" pitchFamily="34" charset="-122"/>
                 <a:cs typeface="Calibri" pitchFamily="34" charset="-120"/>
               </a:rPr>
-              <a:t>uic-laguna-xs2</a:t>
+              <a:t>inkling (thinkingmachines)</a:t>
             </a:r>
             <a:endParaRPr lang="en-US" sz="1600" dirty="0"/>
           </a:p>
@@ -14223,7 +14663,7 @@
                 <a:ea typeface="Calibri" pitchFamily="34" charset="-122"/>
                 <a:cs typeface="Calibri" pitchFamily="34" charset="-120"/>
               </a:rPr>
-              <a:t>nVIDIA A100 (MoE)</a:t>
+              <a:t>OpenRouter</a:t>
             </a:r>
             <a:endParaRPr lang="en-US" sz="1600" dirty="0"/>
           </a:p>
@@ -14262,7 +14702,7 @@
                 <a:ea typeface="Calibri" pitchFamily="34" charset="-122"/>
                 <a:cs typeface="Calibri" pitchFamily="34" charset="-120"/>
               </a:rPr>
-              <a:t>30/30</a:t>
+              <a:t>30/30 (eff.)</a:t>
             </a:r>
             <a:endParaRPr lang="en-US" sz="1600" dirty="0"/>
           </a:p>
@@ -14301,7 +14741,7 @@
                 <a:ea typeface="Calibri" pitchFamily="34" charset="-122"/>
                 <a:cs typeface="Calibri" pitchFamily="34" charset="-120"/>
               </a:rPr>
-              <a:t>49m</a:t>
+              <a:t>24m</a:t>
             </a:r>
             <a:endParaRPr lang="en-US" sz="1600" dirty="0"/>
           </a:p>
@@ -14385,7 +14825,7 @@
                 <a:ea typeface="Calibri" pitchFamily="34" charset="-122"/>
                 <a:cs typeface="Calibri" pitchFamily="34" charset="-120"/>
               </a:rPr>
-              <a:t>uic-qwen36-35b-a3b</a:t>
+              <a:t>uic-laguna-xs2</a:t>
             </a:r>
             <a:endParaRPr lang="en-US" sz="1600" dirty="0"/>
           </a:p>
@@ -14502,7 +14942,7 @@
                 <a:ea typeface="Calibri" pitchFamily="34" charset="-122"/>
                 <a:cs typeface="Calibri" pitchFamily="34" charset="-120"/>
               </a:rPr>
-              <a:t>52m</a:t>
+              <a:t>49m</a:t>
             </a:r>
             <a:endParaRPr lang="en-US" sz="1600" dirty="0"/>
           </a:p>
@@ -14586,7 +15026,7 @@
                 <a:ea typeface="Calibri" pitchFamily="34" charset="-122"/>
                 <a:cs typeface="Calibri" pitchFamily="34" charset="-120"/>
               </a:rPr>
-              <a:t>qwen36-27b</a:t>
+              <a:t>uic-qwen36-35b-a3b</a:t>
             </a:r>
             <a:endParaRPr lang="en-US" sz="1600" dirty="0"/>
           </a:p>
@@ -14625,7 +15065,7 @@
                 <a:ea typeface="Calibri" pitchFamily="34" charset="-122"/>
                 <a:cs typeface="Calibri" pitchFamily="34" charset="-120"/>
               </a:rPr>
-              <a:t>Intel PVC (1 tile)</a:t>
+              <a:t>nVIDIA A100 (MoE)</a:t>
             </a:r>
             <a:endParaRPr lang="en-US" sz="1600" dirty="0"/>
           </a:p>
@@ -14703,7 +15143,7 @@
                 <a:ea typeface="Calibri" pitchFamily="34" charset="-122"/>
                 <a:cs typeface="Calibri" pitchFamily="34" charset="-120"/>
               </a:rPr>
-              <a:t>1h22m</a:t>
+              <a:t>52m</a:t>
             </a:r>
             <a:endParaRPr lang="en-US" sz="1600" dirty="0"/>
           </a:p>
@@ -14787,7 +15227,7 @@
                 <a:ea typeface="Calibri" pitchFamily="34" charset="-122"/>
                 <a:cs typeface="Calibri" pitchFamily="34" charset="-120"/>
               </a:rPr>
-              <a:t>ornith-9b (reasoning)</a:t>
+              <a:t>qwen36-27b</a:t>
             </a:r>
             <a:endParaRPr lang="en-US" sz="1600" dirty="0"/>
           </a:p>
@@ -14904,7 +15344,7 @@
                 <a:ea typeface="Calibri" pitchFamily="34" charset="-122"/>
                 <a:cs typeface="Calibri" pitchFamily="34" charset="-120"/>
               </a:rPr>
-              <a:t>3h05m</a:t>
+              <a:t>1h22m</a:t>
             </a:r>
             <a:endParaRPr lang="en-US" sz="1600" dirty="0"/>
           </a:p>
@@ -14988,7 +15428,7 @@
                 <a:ea typeface="Calibri" pitchFamily="34" charset="-122"/>
                 <a:cs typeface="Calibri" pitchFamily="34" charset="-120"/>
               </a:rPr>
-              <a:t>kimi (Kimi-K2.6)</a:t>
+              <a:t>ornith-9b (reasoning)</a:t>
             </a:r>
             <a:endParaRPr lang="en-US" sz="1600" dirty="0"/>
           </a:p>
@@ -15027,7 +15467,7 @@
                 <a:ea typeface="Calibri" pitchFamily="34" charset="-122"/>
                 <a:cs typeface="Calibri" pitchFamily="34" charset="-120"/>
               </a:rPr>
-              <a:t>local dgx</a:t>
+              <a:t>Intel PVC (1 tile)</a:t>
             </a:r>
             <a:endParaRPr lang="en-US" sz="1600" dirty="0"/>
           </a:p>
@@ -15105,7 +15545,7 @@
                 <a:ea typeface="Calibri" pitchFamily="34" charset="-122"/>
                 <a:cs typeface="Calibri" pitchFamily="34" charset="-120"/>
               </a:rPr>
-              <a:t>3h18m</a:t>
+              <a:t>3h05m</a:t>
             </a:r>
             <a:endParaRPr lang="en-US" sz="1600" dirty="0"/>
           </a:p>
@@ -15189,7 +15629,7 @@
                 <a:ea typeface="Calibri" pitchFamily="34" charset="-122"/>
                 <a:cs typeface="Calibri" pitchFamily="34" charset="-120"/>
               </a:rPr>
-              <a:t>laguna-xs2 (direct)</a:t>
+              <a:t>kimi (Kimi-K2.6)</a:t>
             </a:r>
             <a:endParaRPr lang="en-US" sz="1600" dirty="0"/>
           </a:p>
@@ -15228,7 +15668,7 @@
                 <a:ea typeface="Calibri" pitchFamily="34" charset="-122"/>
                 <a:cs typeface="Calibri" pitchFamily="34" charset="-120"/>
               </a:rPr>
-              <a:t>nVIDIA A100 ik_llama</a:t>
+              <a:t>local dgx</a:t>
             </a:r>
             <a:endParaRPr lang="en-US" sz="1600" dirty="0"/>
           </a:p>
@@ -15267,7 +15707,7 @@
                 <a:ea typeface="Calibri" pitchFamily="34" charset="-122"/>
                 <a:cs typeface="Calibri" pitchFamily="34" charset="-120"/>
               </a:rPr>
-              <a:t>27/30 (eff.30)</a:t>
+              <a:t>30/30</a:t>
             </a:r>
             <a:endParaRPr lang="en-US" sz="1600" dirty="0"/>
           </a:p>
@@ -15306,6 +15746,207 @@
                 <a:ea typeface="Calibri" pitchFamily="34" charset="-122"/>
                 <a:cs typeface="Calibri" pitchFamily="34" charset="-120"/>
               </a:rPr>
+              <a:t>3h18m</a:t>
+            </a:r>
+            <a:endParaRPr lang="en-US" sz="1600" dirty="0"/>
+          </a:p>
+        </p:txBody>
+      </p:sp>
+      <p:sp>
+        <p:nvSpPr>
+          <p:cNvPr id="51" name="Shape 49"/>
+          <p:cNvSpPr/>
+          <p:nvPr/>
+        </p:nvSpPr>
+        <p:spPr>
+          <a:xfrm>
+            <a:off x="640080" y="4855464"/>
+            <a:ext cx="10908792" cy="384048"/>
+          </a:xfrm>
+          <a:prstGeom prst="rect">
+            <a:avLst/>
+          </a:prstGeom>
+          <a:solidFill>
+            <a:srgbClr val="EAF6EC"/>
+          </a:solidFill>
+          <a:ln w="6350">
+            <a:solidFill>
+              <a:srgbClr val="D8E2EE"/>
+            </a:solidFill>
+            <a:prstDash val="solid"/>
+          </a:ln>
+        </p:spPr>
+      </p:sp>
+      <p:sp>
+        <p:nvSpPr>
+          <p:cNvPr id="52" name="Shape 50"/>
+          <p:cNvSpPr/>
+          <p:nvPr/>
+        </p:nvSpPr>
+        <p:spPr>
+          <a:xfrm>
+            <a:off x="640080" y="4855464"/>
+            <a:ext cx="91440" cy="384048"/>
+          </a:xfrm>
+          <a:prstGeom prst="rect">
+            <a:avLst/>
+          </a:prstGeom>
+          <a:solidFill>
+            <a:srgbClr val="3BA776"/>
+          </a:solidFill>
+          <a:ln/>
+        </p:spPr>
+      </p:sp>
+      <p:sp>
+        <p:nvSpPr>
+          <p:cNvPr id="53" name="Text 51"/>
+          <p:cNvSpPr/>
+          <p:nvPr/>
+        </p:nvSpPr>
+        <p:spPr>
+          <a:xfrm>
+            <a:off x="777240" y="4855464"/>
+            <a:ext cx="4709160" cy="384048"/>
+          </a:xfrm>
+          <a:prstGeom prst="rect">
+            <a:avLst/>
+          </a:prstGeom>
+          <a:noFill/>
+          <a:ln/>
+        </p:spPr>
+        <p:txBody>
+          <a:bodyPr wrap="square" rtlCol="0" anchor="ctr"/>
+          <a:lstStyle/>
+          <a:p>
+            <a:pPr indent="0" marL="0">
+              <a:buNone/>
+            </a:pPr>
+            <a:r>
+              <a:rPr lang="en-US" sz="1600" b="1" dirty="0">
+                <a:solidFill>
+                  <a:srgbClr val="14202E"/>
+                </a:solidFill>
+                <a:latin typeface="Calibri" pitchFamily="34" charset="0"/>
+                <a:ea typeface="Calibri" pitchFamily="34" charset="-122"/>
+                <a:cs typeface="Calibri" pitchFamily="34" charset="-120"/>
+              </a:rPr>
+              <a:t>laguna-xs2 (direct)</a:t>
+            </a:r>
+            <a:endParaRPr lang="en-US" sz="1600" dirty="0"/>
+          </a:p>
+        </p:txBody>
+      </p:sp>
+      <p:sp>
+        <p:nvSpPr>
+          <p:cNvPr id="54" name="Text 52"/>
+          <p:cNvSpPr/>
+          <p:nvPr/>
+        </p:nvSpPr>
+        <p:spPr>
+          <a:xfrm>
+            <a:off x="5532120" y="4855464"/>
+            <a:ext cx="3063240" cy="384048"/>
+          </a:xfrm>
+          <a:prstGeom prst="rect">
+            <a:avLst/>
+          </a:prstGeom>
+          <a:noFill/>
+          <a:ln/>
+        </p:spPr>
+        <p:txBody>
+          <a:bodyPr wrap="square" rtlCol="0" anchor="ctr"/>
+          <a:lstStyle/>
+          <a:p>
+            <a:pPr indent="0" marL="0">
+              <a:buNone/>
+            </a:pPr>
+            <a:r>
+              <a:rPr lang="en-US" sz="1600" dirty="0">
+                <a:solidFill>
+                  <a:srgbClr val="33414F"/>
+                </a:solidFill>
+                <a:latin typeface="Calibri" pitchFamily="34" charset="0"/>
+                <a:ea typeface="Calibri" pitchFamily="34" charset="-122"/>
+                <a:cs typeface="Calibri" pitchFamily="34" charset="-120"/>
+              </a:rPr>
+              <a:t>nVIDIA A100 ik_llama</a:t>
+            </a:r>
+            <a:endParaRPr lang="en-US" sz="1600" dirty="0"/>
+          </a:p>
+        </p:txBody>
+      </p:sp>
+      <p:sp>
+        <p:nvSpPr>
+          <p:cNvPr id="55" name="Text 53"/>
+          <p:cNvSpPr/>
+          <p:nvPr/>
+        </p:nvSpPr>
+        <p:spPr>
+          <a:xfrm>
+            <a:off x="8641080" y="4855464"/>
+            <a:ext cx="1737360" cy="384048"/>
+          </a:xfrm>
+          <a:prstGeom prst="rect">
+            <a:avLst/>
+          </a:prstGeom>
+          <a:noFill/>
+          <a:ln/>
+        </p:spPr>
+        <p:txBody>
+          <a:bodyPr wrap="square" rtlCol="0" anchor="ctr"/>
+          <a:lstStyle/>
+          <a:p>
+            <a:pPr algn="ctr" indent="0" marL="0">
+              <a:buNone/>
+            </a:pPr>
+            <a:r>
+              <a:rPr lang="en-US" sz="1600" b="1" dirty="0">
+                <a:solidFill>
+                  <a:srgbClr val="3BA776"/>
+                </a:solidFill>
+                <a:latin typeface="Calibri" pitchFamily="34" charset="0"/>
+                <a:ea typeface="Calibri" pitchFamily="34" charset="-122"/>
+                <a:cs typeface="Calibri" pitchFamily="34" charset="-120"/>
+              </a:rPr>
+              <a:t>27/30 (eff.30)</a:t>
+            </a:r>
+            <a:endParaRPr lang="en-US" sz="1600" dirty="0"/>
+          </a:p>
+        </p:txBody>
+      </p:sp>
+      <p:sp>
+        <p:nvSpPr>
+          <p:cNvPr id="56" name="Text 54"/>
+          <p:cNvSpPr/>
+          <p:nvPr/>
+        </p:nvSpPr>
+        <p:spPr>
+          <a:xfrm>
+            <a:off x="10469880" y="4855464"/>
+            <a:ext cx="960120" cy="384048"/>
+          </a:xfrm>
+          <a:prstGeom prst="rect">
+            <a:avLst/>
+          </a:prstGeom>
+          <a:noFill/>
+          <a:ln/>
+        </p:spPr>
+        <p:txBody>
+          <a:bodyPr wrap="square" rtlCol="0" anchor="ctr"/>
+          <a:lstStyle/>
+          <a:p>
+            <a:pPr algn="l" indent="0" marL="0">
+              <a:buNone/>
+            </a:pPr>
+            <a:r>
+              <a:rPr lang="en-US" sz="1600" dirty="0">
+                <a:solidFill>
+                  <a:srgbClr val="55657A"/>
+                </a:solidFill>
+                <a:latin typeface="Calibri" pitchFamily="34" charset="0"/>
+                <a:ea typeface="Calibri" pitchFamily="34" charset="-122"/>
+                <a:cs typeface="Calibri" pitchFamily="34" charset="-120"/>
+              </a:rPr>
               <a:t>56m</a:t>
             </a:r>
             <a:endParaRPr lang="en-US" sz="1600" dirty="0"/>
@@ -15314,13 +15955,194 @@
       </p:sp>
       <p:sp>
         <p:nvSpPr>
-          <p:cNvPr id="51" name="Shape 49"/>
-          <p:cNvSpPr/>
-          <p:nvPr/>
-        </p:nvSpPr>
-        <p:spPr>
-          <a:xfrm>
-            <a:off x="640080" y="4855464"/>
+          <p:cNvPr id="57" name="Shape 55"/>
+          <p:cNvSpPr/>
+          <p:nvPr/>
+        </p:nvSpPr>
+        <p:spPr>
+          <a:xfrm>
+            <a:off x="640080" y="5239512"/>
+            <a:ext cx="10908792" cy="384048"/>
+          </a:xfrm>
+          <a:prstGeom prst="rect">
+            <a:avLst/>
+          </a:prstGeom>
+          <a:solidFill>
+            <a:srgbClr val="FFFFFF"/>
+          </a:solidFill>
+          <a:ln w="6350">
+            <a:solidFill>
+              <a:srgbClr val="D8E2EE"/>
+            </a:solidFill>
+            <a:prstDash val="solid"/>
+          </a:ln>
+        </p:spPr>
+      </p:sp>
+      <p:sp>
+        <p:nvSpPr>
+          <p:cNvPr id="58" name="Text 56"/>
+          <p:cNvSpPr/>
+          <p:nvPr/>
+        </p:nvSpPr>
+        <p:spPr>
+          <a:xfrm>
+            <a:off x="777240" y="5239512"/>
+            <a:ext cx="4709160" cy="384048"/>
+          </a:xfrm>
+          <a:prstGeom prst="rect">
+            <a:avLst/>
+          </a:prstGeom>
+          <a:noFill/>
+          <a:ln/>
+        </p:spPr>
+        <p:txBody>
+          <a:bodyPr wrap="square" rtlCol="0" anchor="ctr"/>
+          <a:lstStyle/>
+          <a:p>
+            <a:pPr indent="0" marL="0">
+              <a:buNone/>
+            </a:pPr>
+            <a:r>
+              <a:rPr lang="en-US" sz="1600" dirty="0">
+                <a:solidFill>
+                  <a:srgbClr val="14202E"/>
+                </a:solidFill>
+                <a:latin typeface="Calibri" pitchFamily="34" charset="0"/>
+                <a:ea typeface="Calibri" pitchFamily="34" charset="-122"/>
+                <a:cs typeface="Calibri" pitchFamily="34" charset="-120"/>
+              </a:rPr>
+              <a:t>glm-5.2</a:t>
+            </a:r>
+            <a:endParaRPr lang="en-US" sz="1600" dirty="0"/>
+          </a:p>
+        </p:txBody>
+      </p:sp>
+      <p:sp>
+        <p:nvSpPr>
+          <p:cNvPr id="59" name="Text 57"/>
+          <p:cNvSpPr/>
+          <p:nvPr/>
+        </p:nvSpPr>
+        <p:spPr>
+          <a:xfrm>
+            <a:off x="5532120" y="5239512"/>
+            <a:ext cx="3063240" cy="384048"/>
+          </a:xfrm>
+          <a:prstGeom prst="rect">
+            <a:avLst/>
+          </a:prstGeom>
+          <a:noFill/>
+          <a:ln/>
+        </p:spPr>
+        <p:txBody>
+          <a:bodyPr wrap="square" rtlCol="0" anchor="ctr"/>
+          <a:lstStyle/>
+          <a:p>
+            <a:pPr indent="0" marL="0">
+              <a:buNone/>
+            </a:pPr>
+            <a:r>
+              <a:rPr lang="en-US" sz="1600" dirty="0">
+                <a:solidFill>
+                  <a:srgbClr val="33414F"/>
+                </a:solidFill>
+                <a:latin typeface="Calibri" pitchFamily="34" charset="0"/>
+                <a:ea typeface="Calibri" pitchFamily="34" charset="-122"/>
+                <a:cs typeface="Calibri" pitchFamily="34" charset="-120"/>
+              </a:rPr>
+              <a:t>OpenRouter (paid)</a:t>
+            </a:r>
+            <a:endParaRPr lang="en-US" sz="1600" dirty="0"/>
+          </a:p>
+        </p:txBody>
+      </p:sp>
+      <p:sp>
+        <p:nvSpPr>
+          <p:cNvPr id="60" name="Text 58"/>
+          <p:cNvSpPr/>
+          <p:nvPr/>
+        </p:nvSpPr>
+        <p:spPr>
+          <a:xfrm>
+            <a:off x="8641080" y="5239512"/>
+            <a:ext cx="1737360" cy="384048"/>
+          </a:xfrm>
+          <a:prstGeom prst="rect">
+            <a:avLst/>
+          </a:prstGeom>
+          <a:noFill/>
+          <a:ln/>
+        </p:spPr>
+        <p:txBody>
+          <a:bodyPr wrap="square" rtlCol="0" anchor="ctr"/>
+          <a:lstStyle/>
+          <a:p>
+            <a:pPr algn="ctr" indent="0" marL="0">
+              <a:buNone/>
+            </a:pPr>
+            <a:r>
+              <a:rPr lang="en-US" sz="1600" b="1" dirty="0">
+                <a:solidFill>
+                  <a:srgbClr val="14202E"/>
+                </a:solidFill>
+                <a:latin typeface="Calibri" pitchFamily="34" charset="0"/>
+                <a:ea typeface="Calibri" pitchFamily="34" charset="-122"/>
+                <a:cs typeface="Calibri" pitchFamily="34" charset="-120"/>
+              </a:rPr>
+              <a:t>29/30</a:t>
+            </a:r>
+            <a:endParaRPr lang="en-US" sz="1600" dirty="0"/>
+          </a:p>
+        </p:txBody>
+      </p:sp>
+      <p:sp>
+        <p:nvSpPr>
+          <p:cNvPr id="61" name="Text 59"/>
+          <p:cNvSpPr/>
+          <p:nvPr/>
+        </p:nvSpPr>
+        <p:spPr>
+          <a:xfrm>
+            <a:off x="10469880" y="5239512"/>
+            <a:ext cx="960120" cy="384048"/>
+          </a:xfrm>
+          <a:prstGeom prst="rect">
+            <a:avLst/>
+          </a:prstGeom>
+          <a:noFill/>
+          <a:ln/>
+        </p:spPr>
+        <p:txBody>
+          <a:bodyPr wrap="square" rtlCol="0" anchor="ctr"/>
+          <a:lstStyle/>
+          <a:p>
+            <a:pPr algn="l" indent="0" marL="0">
+              <a:buNone/>
+            </a:pPr>
+            <a:r>
+              <a:rPr lang="en-US" sz="1600" dirty="0">
+                <a:solidFill>
+                  <a:srgbClr val="55657A"/>
+                </a:solidFill>
+                <a:latin typeface="Calibri" pitchFamily="34" charset="0"/>
+                <a:ea typeface="Calibri" pitchFamily="34" charset="-122"/>
+                <a:cs typeface="Calibri" pitchFamily="34" charset="-120"/>
+              </a:rPr>
+              <a:t>44m</a:t>
+            </a:r>
+            <a:endParaRPr lang="en-US" sz="1600" dirty="0"/>
+          </a:p>
+        </p:txBody>
+      </p:sp>
+      <p:sp>
+        <p:nvSpPr>
+          <p:cNvPr id="62" name="Shape 60"/>
+          <p:cNvSpPr/>
+          <p:nvPr/>
+        </p:nvSpPr>
+        <p:spPr>
+          <a:xfrm>
+            <a:off x="640080" y="5623560"/>
             <a:ext cx="10908792" cy="384048"/>
           </a:xfrm>
           <a:prstGeom prst="rect">
@@ -15339,13 +16161,13 @@
       </p:sp>
       <p:sp>
         <p:nvSpPr>
-          <p:cNvPr id="52" name="Text 50"/>
-          <p:cNvSpPr/>
-          <p:nvPr/>
-        </p:nvSpPr>
-        <p:spPr>
-          <a:xfrm>
-            <a:off x="777240" y="4855464"/>
+          <p:cNvPr id="63" name="Text 61"/>
+          <p:cNvSpPr/>
+          <p:nvPr/>
+        </p:nvSpPr>
+        <p:spPr>
+          <a:xfrm>
+            <a:off x="777240" y="5623560"/>
             <a:ext cx="4709160" cy="384048"/>
           </a:xfrm>
           <a:prstGeom prst="rect">
@@ -15370,21 +16192,21 @@
                 <a:ea typeface="Calibri" pitchFamily="34" charset="-122"/>
                 <a:cs typeface="Calibri" pitchFamily="34" charset="-120"/>
               </a:rPr>
-              <a:t>glm-5.2</a:t>
-            </a:r>
-            <a:endParaRPr lang="en-US" sz="1600" dirty="0"/>
-          </a:p>
-        </p:txBody>
-      </p:sp>
-      <p:sp>
-        <p:nvSpPr>
-          <p:cNvPr id="53" name="Text 51"/>
-          <p:cNvSpPr/>
-          <p:nvPr/>
-        </p:nvSpPr>
-        <p:spPr>
-          <a:xfrm>
-            <a:off x="5532120" y="4855464"/>
+              <a:t>gemma4-31b</a:t>
+            </a:r>
+            <a:endParaRPr lang="en-US" sz="1600" dirty="0"/>
+          </a:p>
+        </p:txBody>
+      </p:sp>
+      <p:sp>
+        <p:nvSpPr>
+          <p:cNvPr id="64" name="Text 62"/>
+          <p:cNvSpPr/>
+          <p:nvPr/>
+        </p:nvSpPr>
+        <p:spPr>
+          <a:xfrm>
+            <a:off x="5532120" y="5623560"/>
             <a:ext cx="3063240" cy="384048"/>
           </a:xfrm>
           <a:prstGeom prst="rect">
@@ -15409,21 +16231,21 @@
                 <a:ea typeface="Calibri" pitchFamily="34" charset="-122"/>
                 <a:cs typeface="Calibri" pitchFamily="34" charset="-120"/>
               </a:rPr>
-              <a:t>OpenRouter (paid)</a:t>
-            </a:r>
-            <a:endParaRPr lang="en-US" sz="1600" dirty="0"/>
-          </a:p>
-        </p:txBody>
-      </p:sp>
-      <p:sp>
-        <p:nvSpPr>
-          <p:cNvPr id="54" name="Text 52"/>
-          <p:cNvSpPr/>
-          <p:nvPr/>
-        </p:nvSpPr>
-        <p:spPr>
-          <a:xfrm>
-            <a:off x="8641080" y="4855464"/>
+              <a:t>Intel PVC (1 tile)</a:t>
+            </a:r>
+            <a:endParaRPr lang="en-US" sz="1600" dirty="0"/>
+          </a:p>
+        </p:txBody>
+      </p:sp>
+      <p:sp>
+        <p:nvSpPr>
+          <p:cNvPr id="65" name="Text 63"/>
+          <p:cNvSpPr/>
+          <p:nvPr/>
+        </p:nvSpPr>
+        <p:spPr>
+          <a:xfrm>
+            <a:off x="8641080" y="5623560"/>
             <a:ext cx="1737360" cy="384048"/>
           </a:xfrm>
           <a:prstGeom prst="rect">
@@ -15456,13 +16278,13 @@
       </p:sp>
       <p:sp>
         <p:nvSpPr>
-          <p:cNvPr id="55" name="Text 53"/>
-          <p:cNvSpPr/>
-          <p:nvPr/>
-        </p:nvSpPr>
-        <p:spPr>
-          <a:xfrm>
-            <a:off x="10469880" y="4855464"/>
+          <p:cNvPr id="66" name="Text 64"/>
+          <p:cNvSpPr/>
+          <p:nvPr/>
+        </p:nvSpPr>
+        <p:spPr>
+          <a:xfrm>
+            <a:off x="10469880" y="5623560"/>
             <a:ext cx="960120" cy="384048"/>
           </a:xfrm>
           <a:prstGeom prst="rect">
@@ -15487,21 +16309,21 @@
                 <a:ea typeface="Calibri" pitchFamily="34" charset="-122"/>
                 <a:cs typeface="Calibri" pitchFamily="34" charset="-120"/>
               </a:rPr>
-              <a:t>44m</a:t>
-            </a:r>
-            <a:endParaRPr lang="en-US" sz="1600" dirty="0"/>
-          </a:p>
-        </p:txBody>
-      </p:sp>
-      <p:sp>
-        <p:nvSpPr>
-          <p:cNvPr id="56" name="Shape 54"/>
-          <p:cNvSpPr/>
-          <p:nvPr/>
-        </p:nvSpPr>
-        <p:spPr>
-          <a:xfrm>
-            <a:off x="640080" y="5239512"/>
+              <a:t>3h01m</a:t>
+            </a:r>
+            <a:endParaRPr lang="en-US" sz="1600" dirty="0"/>
+          </a:p>
+        </p:txBody>
+      </p:sp>
+      <p:sp>
+        <p:nvSpPr>
+          <p:cNvPr id="67" name="Shape 65"/>
+          <p:cNvSpPr/>
+          <p:nvPr/>
+        </p:nvSpPr>
+        <p:spPr>
+          <a:xfrm>
+            <a:off x="640080" y="6007608"/>
             <a:ext cx="10908792" cy="384048"/>
           </a:xfrm>
           <a:prstGeom prst="rect">
@@ -15520,13 +16342,13 @@
       </p:sp>
       <p:sp>
         <p:nvSpPr>
-          <p:cNvPr id="57" name="Text 55"/>
-          <p:cNvSpPr/>
-          <p:nvPr/>
-        </p:nvSpPr>
-        <p:spPr>
-          <a:xfrm>
-            <a:off x="777240" y="5239512"/>
+          <p:cNvPr id="68" name="Text 66"/>
+          <p:cNvSpPr/>
+          <p:nvPr/>
+        </p:nvSpPr>
+        <p:spPr>
+          <a:xfrm>
+            <a:off x="777240" y="6007608"/>
             <a:ext cx="4709160" cy="384048"/>
           </a:xfrm>
           <a:prstGeom prst="rect">
@@ -15551,21 +16373,21 @@
                 <a:ea typeface="Calibri" pitchFamily="34" charset="-122"/>
                 <a:cs typeface="Calibri" pitchFamily="34" charset="-120"/>
               </a:rPr>
-              <a:t>gemma4-31b</a:t>
-            </a:r>
-            <a:endParaRPr lang="en-US" sz="1600" dirty="0"/>
-          </a:p>
-        </p:txBody>
-      </p:sp>
-      <p:sp>
-        <p:nvSpPr>
-          <p:cNvPr id="58" name="Text 56"/>
-          <p:cNvSpPr/>
-          <p:nvPr/>
-        </p:nvSpPr>
-        <p:spPr>
-          <a:xfrm>
-            <a:off x="5532120" y="5239512"/>
+              <a:t>uic-ornith-9b (reasoning)</a:t>
+            </a:r>
+            <a:endParaRPr lang="en-US" sz="1600" dirty="0"/>
+          </a:p>
+        </p:txBody>
+      </p:sp>
+      <p:sp>
+        <p:nvSpPr>
+          <p:cNvPr id="69" name="Text 67"/>
+          <p:cNvSpPr/>
+          <p:nvPr/>
+        </p:nvSpPr>
+        <p:spPr>
+          <a:xfrm>
+            <a:off x="5532120" y="6007608"/>
             <a:ext cx="3063240" cy="384048"/>
           </a:xfrm>
           <a:prstGeom prst="rect">
@@ -15590,21 +16412,21 @@
                 <a:ea typeface="Calibri" pitchFamily="34" charset="-122"/>
                 <a:cs typeface="Calibri" pitchFamily="34" charset="-120"/>
               </a:rPr>
-              <a:t>Intel PVC (1 tile)</a:t>
-            </a:r>
-            <a:endParaRPr lang="en-US" sz="1600" dirty="0"/>
-          </a:p>
-        </p:txBody>
-      </p:sp>
-      <p:sp>
-        <p:nvSpPr>
-          <p:cNvPr id="59" name="Text 57"/>
-          <p:cNvSpPr/>
-          <p:nvPr/>
-        </p:nvSpPr>
-        <p:spPr>
-          <a:xfrm>
-            <a:off x="8641080" y="5239512"/>
+              <a:t>nVIDIA A100 llama.cpp</a:t>
+            </a:r>
+            <a:endParaRPr lang="en-US" sz="1600" dirty="0"/>
+          </a:p>
+        </p:txBody>
+      </p:sp>
+      <p:sp>
+        <p:nvSpPr>
+          <p:cNvPr id="70" name="Text 68"/>
+          <p:cNvSpPr/>
+          <p:nvPr/>
+        </p:nvSpPr>
+        <p:spPr>
+          <a:xfrm>
+            <a:off x="8641080" y="6007608"/>
             <a:ext cx="1737360" cy="384048"/>
           </a:xfrm>
           <a:prstGeom prst="rect">
@@ -15629,21 +16451,21 @@
                 <a:ea typeface="Calibri" pitchFamily="34" charset="-122"/>
                 <a:cs typeface="Calibri" pitchFamily="34" charset="-120"/>
               </a:rPr>
-              <a:t>29/30</a:t>
-            </a:r>
-            <a:endParaRPr lang="en-US" sz="1600" dirty="0"/>
-          </a:p>
-        </p:txBody>
-      </p:sp>
-      <p:sp>
-        <p:nvSpPr>
-          <p:cNvPr id="60" name="Text 58"/>
-          <p:cNvSpPr/>
-          <p:nvPr/>
-        </p:nvSpPr>
-        <p:spPr>
-          <a:xfrm>
-            <a:off x="10469880" y="5239512"/>
+              <a:t>28/30</a:t>
+            </a:r>
+            <a:endParaRPr lang="en-US" sz="1600" dirty="0"/>
+          </a:p>
+        </p:txBody>
+      </p:sp>
+      <p:sp>
+        <p:nvSpPr>
+          <p:cNvPr id="71" name="Text 69"/>
+          <p:cNvSpPr/>
+          <p:nvPr/>
+        </p:nvSpPr>
+        <p:spPr>
+          <a:xfrm>
+            <a:off x="10469880" y="6007608"/>
             <a:ext cx="960120" cy="384048"/>
           </a:xfrm>
           <a:prstGeom prst="rect">
@@ -15668,180 +16490,38 @@
                 <a:ea typeface="Calibri" pitchFamily="34" charset="-122"/>
                 <a:cs typeface="Calibri" pitchFamily="34" charset="-120"/>
               </a:rPr>
-              <a:t>3h01m</a:t>
-            </a:r>
-            <a:endParaRPr lang="en-US" sz="1600" dirty="0"/>
-          </a:p>
-        </p:txBody>
-      </p:sp>
-      <p:sp>
-        <p:nvSpPr>
-          <p:cNvPr id="61" name="Shape 59"/>
-          <p:cNvSpPr/>
-          <p:nvPr/>
-        </p:nvSpPr>
-        <p:spPr>
-          <a:xfrm>
-            <a:off x="640080" y="5623560"/>
-            <a:ext cx="10908792" cy="384048"/>
-          </a:xfrm>
-          <a:prstGeom prst="rect">
-            <a:avLst/>
-          </a:prstGeom>
-          <a:solidFill>
-            <a:srgbClr val="F5F8FC"/>
-          </a:solidFill>
-          <a:ln w="6350">
-            <a:solidFill>
-              <a:srgbClr val="D8E2EE"/>
-            </a:solidFill>
-            <a:prstDash val="solid"/>
-          </a:ln>
-        </p:spPr>
-      </p:sp>
-      <p:sp>
-        <p:nvSpPr>
-          <p:cNvPr id="62" name="Text 60"/>
-          <p:cNvSpPr/>
-          <p:nvPr/>
-        </p:nvSpPr>
-        <p:spPr>
-          <a:xfrm>
-            <a:off x="777240" y="5623560"/>
-            <a:ext cx="4709160" cy="384048"/>
-          </a:xfrm>
-          <a:prstGeom prst="rect">
-            <a:avLst/>
-          </a:prstGeom>
-          <a:noFill/>
-          <a:ln/>
-        </p:spPr>
-        <p:txBody>
-          <a:bodyPr wrap="square" rtlCol="0" anchor="ctr"/>
-          <a:lstStyle/>
-          <a:p>
-            <a:pPr indent="0" marL="0">
-              <a:buNone/>
-            </a:pPr>
-            <a:r>
-              <a:rPr lang="en-US" sz="1600" dirty="0">
-                <a:solidFill>
-                  <a:srgbClr val="14202E"/>
-                </a:solidFill>
-                <a:latin typeface="Calibri" pitchFamily="34" charset="0"/>
-                <a:ea typeface="Calibri" pitchFamily="34" charset="-122"/>
-                <a:cs typeface="Calibri" pitchFamily="34" charset="-120"/>
-              </a:rPr>
-              <a:t>uic-ornith-9b (reasoning)</a:t>
-            </a:r>
-            <a:endParaRPr lang="en-US" sz="1600" dirty="0"/>
-          </a:p>
-        </p:txBody>
-      </p:sp>
-      <p:sp>
-        <p:nvSpPr>
-          <p:cNvPr id="63" name="Text 61"/>
-          <p:cNvSpPr/>
-          <p:nvPr/>
-        </p:nvSpPr>
-        <p:spPr>
-          <a:xfrm>
-            <a:off x="5532120" y="5623560"/>
-            <a:ext cx="3063240" cy="384048"/>
-          </a:xfrm>
-          <a:prstGeom prst="rect">
-            <a:avLst/>
-          </a:prstGeom>
-          <a:noFill/>
-          <a:ln/>
-        </p:spPr>
-        <p:txBody>
-          <a:bodyPr wrap="square" rtlCol="0" anchor="ctr"/>
-          <a:lstStyle/>
-          <a:p>
-            <a:pPr indent="0" marL="0">
-              <a:buNone/>
-            </a:pPr>
-            <a:r>
-              <a:rPr lang="en-US" sz="1600" dirty="0">
-                <a:solidFill>
-                  <a:srgbClr val="33414F"/>
-                </a:solidFill>
-                <a:latin typeface="Calibri" pitchFamily="34" charset="0"/>
-                <a:ea typeface="Calibri" pitchFamily="34" charset="-122"/>
-                <a:cs typeface="Calibri" pitchFamily="34" charset="-120"/>
-              </a:rPr>
-              <a:t>nVIDIA A100 llama.cpp</a:t>
-            </a:r>
-            <a:endParaRPr lang="en-US" sz="1600" dirty="0"/>
-          </a:p>
-        </p:txBody>
-      </p:sp>
-      <p:sp>
-        <p:nvSpPr>
-          <p:cNvPr id="64" name="Text 62"/>
-          <p:cNvSpPr/>
-          <p:nvPr/>
-        </p:nvSpPr>
-        <p:spPr>
-          <a:xfrm>
-            <a:off x="8641080" y="5623560"/>
-            <a:ext cx="1737360" cy="384048"/>
-          </a:xfrm>
-          <a:prstGeom prst="rect">
-            <a:avLst/>
-          </a:prstGeom>
-          <a:noFill/>
-          <a:ln/>
-        </p:spPr>
-        <p:txBody>
-          <a:bodyPr wrap="square" rtlCol="0" anchor="ctr"/>
-          <a:lstStyle/>
-          <a:p>
-            <a:pPr algn="ctr" indent="0" marL="0">
-              <a:buNone/>
-            </a:pPr>
-            <a:r>
-              <a:rPr lang="en-US" sz="1600" b="1" dirty="0">
-                <a:solidFill>
-                  <a:srgbClr val="14202E"/>
-                </a:solidFill>
-                <a:latin typeface="Calibri" pitchFamily="34" charset="0"/>
-                <a:ea typeface="Calibri" pitchFamily="34" charset="-122"/>
-                <a:cs typeface="Calibri" pitchFamily="34" charset="-120"/>
-              </a:rPr>
-              <a:t>28/30</a:t>
-            </a:r>
-            <a:endParaRPr lang="en-US" sz="1600" dirty="0"/>
-          </a:p>
-        </p:txBody>
-      </p:sp>
-      <p:sp>
-        <p:nvSpPr>
-          <p:cNvPr id="65" name="Text 63"/>
-          <p:cNvSpPr/>
-          <p:nvPr/>
-        </p:nvSpPr>
-        <p:spPr>
-          <a:xfrm>
-            <a:off x="10469880" y="5623560"/>
-            <a:ext cx="960120" cy="384048"/>
-          </a:xfrm>
-          <a:prstGeom prst="rect">
-            <a:avLst/>
-          </a:prstGeom>
-          <a:noFill/>
-          <a:ln/>
-        </p:spPr>
-        <p:txBody>
-          <a:bodyPr wrap="square" rtlCol="0" anchor="ctr"/>
-          <a:lstStyle/>
-          <a:p>
-            <a:pPr algn="l" indent="0" marL="0">
-              <a:buNone/>
-            </a:pPr>
-            <a:r>
-              <a:rPr lang="en-US" sz="1600" dirty="0">
+              <a:t>1h36m</a:t>
+            </a:r>
+            <a:endParaRPr lang="en-US" sz="1600" dirty="0"/>
+          </a:p>
+        </p:txBody>
+      </p:sp>
+      <p:sp>
+        <p:nvSpPr>
+          <p:cNvPr id="72" name="Text 70"/>
+          <p:cNvSpPr/>
+          <p:nvPr/>
+        </p:nvSpPr>
+        <p:spPr>
+          <a:xfrm>
+            <a:off x="640080" y="6446520"/>
+            <a:ext cx="10881360" cy="411480"/>
+          </a:xfrm>
+          <a:prstGeom prst="rect">
+            <a:avLst/>
+          </a:prstGeom>
+          <a:noFill/>
+          <a:ln/>
+        </p:spPr>
+        <p:txBody>
+          <a:bodyPr wrap="square" rtlCol="0" anchor="ctr"/>
+          <a:lstStyle/>
+          <a:p>
+            <a:pPr indent="0" marL="0">
+              <a:buNone/>
+            </a:pPr>
+            <a:r>
+              <a:rPr lang="en-US" sz="1600" i="1" dirty="0">
                 <a:solidFill>
                   <a:srgbClr val="55657A"/>
                 </a:solidFill>
@@ -15849,45 +16529,6 @@
                 <a:ea typeface="Calibri" pitchFamily="34" charset="-122"/>
                 <a:cs typeface="Calibri" pitchFamily="34" charset="-120"/>
               </a:rPr>
-              <a:t>1h36m</a:t>
-            </a:r>
-            <a:endParaRPr lang="en-US" sz="1600" dirty="0"/>
-          </a:p>
-        </p:txBody>
-      </p:sp>
-      <p:sp>
-        <p:nvSpPr>
-          <p:cNvPr id="66" name="Text 64"/>
-          <p:cNvSpPr/>
-          <p:nvPr/>
-        </p:nvSpPr>
-        <p:spPr>
-          <a:xfrm>
-            <a:off x="640080" y="6062472"/>
-            <a:ext cx="10881360" cy="411480"/>
-          </a:xfrm>
-          <a:prstGeom prst="rect">
-            <a:avLst/>
-          </a:prstGeom>
-          <a:noFill/>
-          <a:ln/>
-        </p:spPr>
-        <p:txBody>
-          <a:bodyPr wrap="square" rtlCol="0" anchor="ctr"/>
-          <a:lstStyle/>
-          <a:p>
-            <a:pPr indent="0" marL="0">
-              <a:buNone/>
-            </a:pPr>
-            <a:r>
-              <a:rPr lang="en-US" sz="1600" i="1" dirty="0">
-                <a:solidFill>
-                  <a:srgbClr val="55657A"/>
-                </a:solidFill>
-                <a:latin typeface="Calibri" pitchFamily="34" charset="0"/>
-                <a:ea typeface="Calibri" pitchFamily="34" charset="-122"/>
-                <a:cs typeface="Calibri" pitchFamily="34" charset="-120"/>
-              </a:rPr>
               <a:t>Green = clean 30/30. A 9B model (ornith-9b) hits 30/30 — size is not the gate; tool-use training + a correct serving stack are.</a:t>
             </a:r>
             <a:endParaRPr lang="en-US" sz="1600" dirty="0"/>
@@ -15896,7 +16537,7 @@
       </p:sp>
       <p:sp>
         <p:nvSpPr>
-          <p:cNvPr id="67" name="Text 65"/>
+          <p:cNvPr id="73" name="Text 71"/>
           <p:cNvSpPr/>
           <p:nvPr/>
         </p:nvSpPr>

</xml_diff>